<commit_message>
docs(submission): deck finished (deterministic build, measured cost on slide 10); ADK agents wording in brief, README and deck content
Co-Authored-By: Claude Opus 5.5 (1M context) <noreply@anthropic.com>
</commit_message>
<xml_diff>
--- a/docs/submission/deck/Kirchhoff-AI-Builder-Cup.pptx
+++ b/docs/submission/deck/Kirchhoff-AI-Builder-Cup.pptx
@@ -894,7 +894,7 @@
           <a:lstStyle/>
           <a:p>
             <a:r>
-              <a:t>Cost. The prototype runs on one warm API instance with no CPU throttling, scaling to a maximum of 3 (spec). The enterprise sandbox is a second small service. Gemini 3.8 Flash costs $0.75 per million input tokens and $3.75 per million output tokens through 31 December 2026, and the price doubles from 1 January 2027.¹² The engine does the heavy work without tokens. A what-if runs in about 8 ms and makes no LLM call. Budget alerts fire at 50% and 90% (spec). [TBD: Gemini tokens and USD per full run, measured from the recorded run (spec §4, metric 4).]</a:t>
+              <a:t>Cost. The prototype runs on one warm API instance with no CPU throttling, scaling to a maximum of 3 (spec). The enterprise sandbox is a second small service. Gemini 3.8 Flash costs $0.75 per million input tokens and $3.75 per million output tokens through 31 December 2026, and the price doubles from 1 January 2027.¹² The engine does the heavy work without tokens. A what-if runs in about 8 ms and makes no LLM call. Budget alerts fire at 50% and 90% (spec). Measured on a live run, 15 Oct 2026: a full P1→P4 run on Vertex AI took 176.5 s and used 10,432 input tokens and 12,991 output tokens, about $0.057 per design at $0.75 per million input and $3.75 per million output tokens. The golden capture may replace this figure.</a:t>
             </a:r>
           </a:p>
           <a:p/>
@@ -2327,7 +2327,7 @@
           </a:p>
           <a:p>
             <a:r>
-              <a:t>- ADK graphs order the agents, the tools, the gates and the fix loop.</a:t>
+              <a:t>- ADK agents call engine tools; the run orchestrator orders the phases, the gates and the fix loop.</a:t>
             </a:r>
           </a:p>
           <a:p>
@@ -7921,7 +7921,7 @@
                 <a:spcPct val="100000"/>
               </a:lnSpc>
               <a:spcAft>
-                <a:spcPts val="400"/>
+                <a:spcPts val="380"/>
               </a:spcAft>
               <a:buClr>
                 <a:srgbClr val="80868B"/>
@@ -7930,7 +7930,7 @@
               <a:buChar char="•"/>
             </a:pPr>
             <a:r>
-              <a:rPr sz="1200" b="0" lang="en-GB">
+              <a:rPr sz="1150" b="0" lang="en-GB">
                 <a:solidFill>
                   <a:srgbClr val="3C4043"/>
                 </a:solidFill>
@@ -7939,7 +7939,7 @@
               <a:t>1 warm Cloud Run instance</a:t>
             </a:r>
             <a:r>
-              <a:rPr sz="950" b="0" lang="en-GB">
+              <a:rPr sz="900" b="0" lang="en-GB">
                 <a:solidFill>
                   <a:srgbClr val="8A4B00"/>
                 </a:solidFill>
@@ -7957,7 +7957,7 @@
                 <a:spcPct val="100000"/>
               </a:lnSpc>
               <a:spcAft>
-                <a:spcPts val="400"/>
+                <a:spcPts val="380"/>
               </a:spcAft>
               <a:buClr>
                 <a:srgbClr val="80868B"/>
@@ -7966,7 +7966,7 @@
               <a:buChar char="•"/>
             </a:pPr>
             <a:r>
-              <a:rPr sz="1200" b="0" lang="en-GB">
+              <a:rPr sz="1150" b="0" lang="en-GB">
                 <a:solidFill>
                   <a:srgbClr val="3C4043"/>
                 </a:solidFill>
@@ -7975,7 +7975,7 @@
               <a:t>USD 200 budget with alerts</a:t>
             </a:r>
             <a:r>
-              <a:rPr sz="950" b="0" lang="en-GB">
+              <a:rPr sz="900" b="0" lang="en-GB">
                 <a:solidFill>
                   <a:srgbClr val="8A4B00"/>
                 </a:solidFill>
@@ -7993,7 +7993,7 @@
                 <a:spcPct val="100000"/>
               </a:lnSpc>
               <a:spcAft>
-                <a:spcPts val="400"/>
+                <a:spcPts val="380"/>
               </a:spcAft>
               <a:buClr>
                 <a:srgbClr val="80868B"/>
@@ -8002,7 +8002,7 @@
               <a:buChar char="•"/>
             </a:pPr>
             <a:r>
-              <a:rPr sz="1200" b="0" lang="en-GB">
+              <a:rPr sz="1150" b="0" lang="en-GB">
                 <a:solidFill>
                   <a:srgbClr val="3C4043"/>
                 </a:solidFill>
@@ -8017,7 +8017,7 @@
                 <a:spcPct val="100000"/>
               </a:lnSpc>
               <a:spcAft>
-                <a:spcPts val="400"/>
+                <a:spcPts val="380"/>
               </a:spcAft>
               <a:buClr>
                 <a:srgbClr val="80868B"/>
@@ -8026,7 +8026,7 @@
               <a:buChar char="•"/>
             </a:pPr>
             <a:r>
-              <a:rPr sz="1200" b="0" lang="en-GB">
+              <a:rPr sz="1150" b="0" lang="en-GB">
                 <a:solidFill>
                   <a:srgbClr val="3C4043"/>
                 </a:solidFill>
@@ -8035,16 +8035,13 @@
               <a:t>Per design: </a:t>
             </a:r>
             <a:r>
-              <a:rPr sz="1200" b="0" lang="en-GB">
-                <a:solidFill>
-                  <a:srgbClr val="5C3D00"/>
-                </a:solidFill>
-                <a:highlight>
-                  <a:srgbClr val="FFE58F"/>
-                </a:highlight>
-                <a:latin typeface="Google Sans Flex SemiBold"/>
-              </a:rPr>
-              <a:t>[TBD: measured USD per run]</a:t>
+              <a:rPr sz="1150" b="0" lang="en-GB">
+                <a:solidFill>
+                  <a:srgbClr val="3C4043"/>
+                </a:solidFill>
+                <a:latin typeface="Google Sans Flex"/>
+              </a:rPr>
+              <a:t>~$0.057 (measured on a live run, 15 Oct 2026)</a:t>
             </a:r>
           </a:p>
         </p:txBody>
@@ -12554,7 +12551,41 @@
                 </a:solidFill>
                 <a:latin typeface="Google Sans Flex"/>
               </a:rPr>
-              <a:t>QR appears when the URL is filled</a:t>
+              <a:t>QR appears</a:t>
+            </a:r>
+          </a:p>
+          <a:p>
+            <a:pPr algn="ctr" marL="0" indent="0">
+              <a:lnSpc>
+                <a:spcPct val="100000"/>
+              </a:lnSpc>
+              <a:buNone/>
+            </a:pPr>
+            <a:r>
+              <a:rPr sz="650" b="0" lang="en-GB">
+                <a:solidFill>
+                  <a:srgbClr val="9A3412"/>
+                </a:solidFill>
+                <a:latin typeface="Google Sans Flex"/>
+              </a:rPr>
+              <a:t>when the</a:t>
+            </a:r>
+          </a:p>
+          <a:p>
+            <a:pPr algn="ctr" marL="0" indent="0">
+              <a:lnSpc>
+                <a:spcPct val="100000"/>
+              </a:lnSpc>
+              <a:buNone/>
+            </a:pPr>
+            <a:r>
+              <a:rPr sz="650" b="0" lang="en-GB">
+                <a:solidFill>
+                  <a:srgbClr val="9A3412"/>
+                </a:solidFill>
+                <a:latin typeface="Google Sans Flex"/>
+              </a:rPr>
+              <a:t>URL is filled</a:t>
             </a:r>
           </a:p>
         </p:txBody>
@@ -12813,7 +12844,41 @@
                 </a:solidFill>
                 <a:latin typeface="Google Sans Flex"/>
               </a:rPr>
-              <a:t>QR appears when the URL is filled</a:t>
+              <a:t>QR appears</a:t>
+            </a:r>
+          </a:p>
+          <a:p>
+            <a:pPr algn="ctr" marL="0" indent="0">
+              <a:lnSpc>
+                <a:spcPct val="100000"/>
+              </a:lnSpc>
+              <a:buNone/>
+            </a:pPr>
+            <a:r>
+              <a:rPr sz="650" b="0" lang="en-GB">
+                <a:solidFill>
+                  <a:srgbClr val="9A3412"/>
+                </a:solidFill>
+                <a:latin typeface="Google Sans Flex"/>
+              </a:rPr>
+              <a:t>when the</a:t>
+            </a:r>
+          </a:p>
+          <a:p>
+            <a:pPr algn="ctr" marL="0" indent="0">
+              <a:lnSpc>
+                <a:spcPct val="100000"/>
+              </a:lnSpc>
+              <a:buNone/>
+            </a:pPr>
+            <a:r>
+              <a:rPr sz="650" b="0" lang="en-GB">
+                <a:solidFill>
+                  <a:srgbClr val="9A3412"/>
+                </a:solidFill>
+                <a:latin typeface="Google Sans Flex"/>
+              </a:rPr>
+              <a:t>URL is filled</a:t>
             </a:r>
           </a:p>
         </p:txBody>

</xml_diff>

<commit_message>
docs(submission): team headshots on slide 15 (square, metadata stripped) and the GitHub link on slide 14
Co-Authored-By: Claude Opus 5.5 (1M context) <noreply@anthropic.com>
</commit_message>
<xml_diff>
--- a/docs/submission/deck/Kirchhoff-AI-Builder-Cup.pptx
+++ b/docs/submission/deck/Kirchhoff-AI-Builder-Cup.pptx
@@ -12494,6 +12494,203 @@
             <a:r>
               <a:rPr sz="1500" b="0" lang="en-GB">
                 <a:solidFill>
+                  <a:srgbClr val="202124"/>
+                </a:solidFill>
+                <a:latin typeface="Roboto Mono"/>
+                <a:hlinkClick r:id="rId6">
+                  <a:extLst>
+                    <a:ext uri="{A12FA001-AC4F-418D-AE19-62706E023703}">
+                      <ahyp:hlinkClr val="tx"/>
+                    </a:ext>
+                  </a:extLst>
+                </a:hlinkClick>
+              </a:rPr>
+              <a:t>https://github.com/mehular0ra/kirchhoff</a:t>
+            </a:r>
+          </a:p>
+        </p:txBody>
+      </p:sp>
+      <p:pic>
+        <p:nvPicPr>
+          <p:cNvPr id="165" name="QR GitHub Public Repository" descr="image.png"/>
+          <p:cNvPicPr>
+            <a:picLocks noChangeAspect="1"/>
+          </p:cNvPicPr>
+          <p:nvPr/>
+        </p:nvPicPr>
+        <p:blipFill>
+          <a:blip r:embed="rId7"/>
+          <a:stretch>
+            <a:fillRect/>
+          </a:stretch>
+        </p:blipFill>
+        <p:spPr>
+          <a:xfrm>
+            <a:off x="7781544" y="1261872"/>
+            <a:ext cx="822960" cy="822960"/>
+          </a:xfrm>
+          <a:prstGeom prst="rect">
+            <a:avLst/>
+          </a:prstGeom>
+        </p:spPr>
+      </p:pic>
+      <p:sp>
+        <p:nvSpPr>
+          <p:cNvPr id="166" name="link row"/>
+          <p:cNvSpPr/>
+          <p:nvPr/>
+        </p:nvSpPr>
+        <p:spPr>
+          <a:xfrm>
+            <a:off x="356616" y="2322576"/>
+            <a:ext cx="8430768" cy="1078992"/>
+          </a:xfrm>
+          <a:prstGeom prst="roundRect">
+            <a:avLst>
+              <a:gd name="adj" fmla="val 6779"/>
+            </a:avLst>
+          </a:prstGeom>
+          <a:solidFill>
+            <a:srgbClr val="F8F9FA"/>
+          </a:solidFill>
+          <a:ln w="9525">
+            <a:solidFill>
+              <a:srgbClr val="E8EAED"/>
+            </a:solidFill>
+          </a:ln>
+        </p:spPr>
+        <p:txBody>
+          <a:bodyPr rtlCol="0" anchor="ctr" lIns="0" rIns="0" tIns="0" bIns="0"/>
+          <a:lstStyle/>
+          <a:p>
+            <a:pPr algn="ctr"/>
+          </a:p>
+        </p:txBody>
+      </p:sp>
+      <p:sp>
+        <p:nvSpPr>
+          <p:cNvPr id="167" name="badge circle-play"/>
+          <p:cNvSpPr/>
+          <p:nvPr/>
+        </p:nvSpPr>
+        <p:spPr>
+          <a:xfrm>
+            <a:off x="557784" y="2633472"/>
+            <a:ext cx="457200" cy="457200"/>
+          </a:xfrm>
+          <a:prstGeom prst="ellipse">
+            <a:avLst/>
+          </a:prstGeom>
+          <a:solidFill>
+            <a:srgbClr val="FFFFFF"/>
+          </a:solidFill>
+          <a:ln>
+            <a:noFill/>
+          </a:ln>
+        </p:spPr>
+        <p:txBody>
+          <a:bodyPr rtlCol="0" anchor="ctr" lIns="0" rIns="0" tIns="0" bIns="0"/>
+          <a:lstStyle/>
+          <a:p>
+            <a:pPr algn="ctr"/>
+          </a:p>
+        </p:txBody>
+      </p:sp>
+      <p:pic>
+        <p:nvPicPr>
+          <p:cNvPr id="168" name="icon circle-play" descr=""/>
+          <p:cNvPicPr>
+            <a:picLocks noChangeAspect="1"/>
+          </p:cNvPicPr>
+          <p:nvPr/>
+        </p:nvPicPr>
+        <p:blipFill>
+          <a:blip r:embed="rId8"/>
+          <a:stretch>
+            <a:fillRect/>
+          </a:stretch>
+        </p:blipFill>
+        <p:spPr>
+          <a:xfrm>
+            <a:off x="667512" y="2743200"/>
+            <a:ext cx="237744" cy="237744"/>
+          </a:xfrm>
+          <a:prstGeom prst="rect">
+            <a:avLst/>
+          </a:prstGeom>
+        </p:spPr>
+      </p:pic>
+      <p:sp>
+        <p:nvSpPr>
+          <p:cNvPr id="169" name="template prompt"/>
+          <p:cNvSpPr txBox="1"/>
+          <p:nvPr/>
+        </p:nvSpPr>
+        <p:spPr>
+          <a:xfrm>
+            <a:off x="1225296" y="2468880"/>
+            <a:ext cx="6035040" cy="219456"/>
+          </a:xfrm>
+          <a:prstGeom prst="rect">
+            <a:avLst/>
+          </a:prstGeom>
+          <a:noFill/>
+        </p:spPr>
+        <p:txBody>
+          <a:bodyPr wrap="square" lIns="0" tIns="0" rIns="0" bIns="0" anchor="t">
+            <a:noAutofit/>
+          </a:bodyPr>
+          <a:lstStyle/>
+          <a:p>
+            <a:pPr algn="l" marL="0" indent="0">
+              <a:lnSpc>
+                <a:spcPct val="100000"/>
+              </a:lnSpc>
+              <a:buNone/>
+            </a:pPr>
+            <a:r>
+              <a:rPr sz="1050" b="0" lang="en-GB">
+                <a:solidFill>
+                  <a:srgbClr val="5F6368"/>
+                </a:solidFill>
+                <a:latin typeface="Google Sans Flex Medium"/>
+              </a:rPr>
+              <a:t>Demo Video Link (3 Minutes)</a:t>
+            </a:r>
+          </a:p>
+        </p:txBody>
+      </p:sp>
+      <p:sp>
+        <p:nvSpPr>
+          <p:cNvPr id="170" name="link url"/>
+          <p:cNvSpPr txBox="1"/>
+          <p:nvPr/>
+        </p:nvSpPr>
+        <p:spPr>
+          <a:xfrm>
+            <a:off x="1225296" y="2706624"/>
+            <a:ext cx="6172200" cy="329184"/>
+          </a:xfrm>
+          <a:prstGeom prst="rect">
+            <a:avLst/>
+          </a:prstGeom>
+          <a:noFill/>
+        </p:spPr>
+        <p:txBody>
+          <a:bodyPr wrap="square" lIns="0" tIns="0" rIns="0" bIns="0" anchor="ctr">
+            <a:noAutofit/>
+          </a:bodyPr>
+          <a:lstStyle/>
+          <a:p>
+            <a:pPr algn="l" marL="0" indent="0">
+              <a:lnSpc>
+                <a:spcPct val="100000"/>
+              </a:lnSpc>
+              <a:buNone/>
+            </a:pPr>
+            <a:r>
+              <a:rPr sz="1500" b="0" lang="en-GB">
+                <a:solidFill>
                   <a:srgbClr val="5C3D00"/>
                 </a:solidFill>
                 <a:highlight>
@@ -12501,20 +12698,60 @@
                 </a:highlight>
                 <a:latin typeface="Google Sans Flex SemiBold"/>
               </a:rPr>
-              <a:t>[TBD: https://github.com/&lt;org&gt;/kirchhoff]</a:t>
-            </a:r>
-          </a:p>
-        </p:txBody>
-      </p:sp>
-      <p:sp>
-        <p:nvSpPr>
-          <p:cNvPr id="165" name="QR placeholder"/>
+              <a:t>[TBD: video URL]</a:t>
+            </a:r>
+          </a:p>
+        </p:txBody>
+      </p:sp>
+      <p:sp>
+        <p:nvSpPr>
+          <p:cNvPr id="171" name="link note"/>
+          <p:cNvSpPr txBox="1"/>
+          <p:nvPr/>
+        </p:nvSpPr>
+        <p:spPr>
+          <a:xfrm>
+            <a:off x="1225296" y="3054096"/>
+            <a:ext cx="6172200" cy="219456"/>
+          </a:xfrm>
+          <a:prstGeom prst="rect">
+            <a:avLst/>
+          </a:prstGeom>
+          <a:noFill/>
+        </p:spPr>
+        <p:txBody>
+          <a:bodyPr wrap="square" lIns="0" tIns="0" rIns="0" bIns="0" anchor="t">
+            <a:noAutofit/>
+          </a:bodyPr>
+          <a:lstStyle/>
+          <a:p>
+            <a:pPr algn="l" marL="0" indent="0">
+              <a:lnSpc>
+                <a:spcPct val="100000"/>
+              </a:lnSpc>
+              <a:buNone/>
+            </a:pPr>
+            <a:r>
+              <a:rPr sz="950" b="0" lang="en-GB">
+                <a:solidFill>
+                  <a:srgbClr val="5F6368"/>
+                </a:solidFill>
+                <a:latin typeface="Google Sans Flex"/>
+              </a:rPr>
+              <a:t>(runs 2:45)</a:t>
+            </a:r>
+          </a:p>
+        </p:txBody>
+      </p:sp>
+      <p:sp>
+        <p:nvSpPr>
+          <p:cNvPr id="172" name="QR placeholder"/>
           <p:cNvSpPr/>
           <p:nvPr/>
         </p:nvSpPr>
         <p:spPr>
           <a:xfrm>
-            <a:off x="7781544" y="1261872"/>
+            <a:off x="7781544" y="2450592"/>
             <a:ext cx="822960" cy="822960"/>
           </a:xfrm>
           <a:prstGeom prst="roundRect">
@@ -12592,13 +12829,13 @@
       </p:sp>
       <p:sp>
         <p:nvSpPr>
-          <p:cNvPr id="166" name="link row"/>
+          <p:cNvPr id="173" name="link row"/>
           <p:cNvSpPr/>
           <p:nvPr/>
         </p:nvSpPr>
         <p:spPr>
           <a:xfrm>
-            <a:off x="356616" y="2322576"/>
+            <a:off x="356616" y="3511296"/>
             <a:ext cx="8430768" cy="1078992"/>
           </a:xfrm>
           <a:prstGeom prst="roundRect">
@@ -12625,299 +12862,6 @@
       </p:sp>
       <p:sp>
         <p:nvSpPr>
-          <p:cNvPr id="167" name="badge circle-play"/>
-          <p:cNvSpPr/>
-          <p:nvPr/>
-        </p:nvSpPr>
-        <p:spPr>
-          <a:xfrm>
-            <a:off x="557784" y="2633472"/>
-            <a:ext cx="457200" cy="457200"/>
-          </a:xfrm>
-          <a:prstGeom prst="ellipse">
-            <a:avLst/>
-          </a:prstGeom>
-          <a:solidFill>
-            <a:srgbClr val="FFFFFF"/>
-          </a:solidFill>
-          <a:ln>
-            <a:noFill/>
-          </a:ln>
-        </p:spPr>
-        <p:txBody>
-          <a:bodyPr rtlCol="0" anchor="ctr" lIns="0" rIns="0" tIns="0" bIns="0"/>
-          <a:lstStyle/>
-          <a:p>
-            <a:pPr algn="ctr"/>
-          </a:p>
-        </p:txBody>
-      </p:sp>
-      <p:pic>
-        <p:nvPicPr>
-          <p:cNvPr id="168" name="icon circle-play" descr=""/>
-          <p:cNvPicPr>
-            <a:picLocks noChangeAspect="1"/>
-          </p:cNvPicPr>
-          <p:nvPr/>
-        </p:nvPicPr>
-        <p:blipFill>
-          <a:blip r:embed="rId6"/>
-          <a:stretch>
-            <a:fillRect/>
-          </a:stretch>
-        </p:blipFill>
-        <p:spPr>
-          <a:xfrm>
-            <a:off x="667512" y="2743200"/>
-            <a:ext cx="237744" cy="237744"/>
-          </a:xfrm>
-          <a:prstGeom prst="rect">
-            <a:avLst/>
-          </a:prstGeom>
-        </p:spPr>
-      </p:pic>
-      <p:sp>
-        <p:nvSpPr>
-          <p:cNvPr id="169" name="template prompt"/>
-          <p:cNvSpPr txBox="1"/>
-          <p:nvPr/>
-        </p:nvSpPr>
-        <p:spPr>
-          <a:xfrm>
-            <a:off x="1225296" y="2468880"/>
-            <a:ext cx="6035040" cy="219456"/>
-          </a:xfrm>
-          <a:prstGeom prst="rect">
-            <a:avLst/>
-          </a:prstGeom>
-          <a:noFill/>
-        </p:spPr>
-        <p:txBody>
-          <a:bodyPr wrap="square" lIns="0" tIns="0" rIns="0" bIns="0" anchor="t">
-            <a:noAutofit/>
-          </a:bodyPr>
-          <a:lstStyle/>
-          <a:p>
-            <a:pPr algn="l" marL="0" indent="0">
-              <a:lnSpc>
-                <a:spcPct val="100000"/>
-              </a:lnSpc>
-              <a:buNone/>
-            </a:pPr>
-            <a:r>
-              <a:rPr sz="1050" b="0" lang="en-GB">
-                <a:solidFill>
-                  <a:srgbClr val="5F6368"/>
-                </a:solidFill>
-                <a:latin typeface="Google Sans Flex Medium"/>
-              </a:rPr>
-              <a:t>Demo Video Link (3 Minutes)</a:t>
-            </a:r>
-          </a:p>
-        </p:txBody>
-      </p:sp>
-      <p:sp>
-        <p:nvSpPr>
-          <p:cNvPr id="170" name="link url"/>
-          <p:cNvSpPr txBox="1"/>
-          <p:nvPr/>
-        </p:nvSpPr>
-        <p:spPr>
-          <a:xfrm>
-            <a:off x="1225296" y="2706624"/>
-            <a:ext cx="6172200" cy="329184"/>
-          </a:xfrm>
-          <a:prstGeom prst="rect">
-            <a:avLst/>
-          </a:prstGeom>
-          <a:noFill/>
-        </p:spPr>
-        <p:txBody>
-          <a:bodyPr wrap="square" lIns="0" tIns="0" rIns="0" bIns="0" anchor="ctr">
-            <a:noAutofit/>
-          </a:bodyPr>
-          <a:lstStyle/>
-          <a:p>
-            <a:pPr algn="l" marL="0" indent="0">
-              <a:lnSpc>
-                <a:spcPct val="100000"/>
-              </a:lnSpc>
-              <a:buNone/>
-            </a:pPr>
-            <a:r>
-              <a:rPr sz="1500" b="0" lang="en-GB">
-                <a:solidFill>
-                  <a:srgbClr val="5C3D00"/>
-                </a:solidFill>
-                <a:highlight>
-                  <a:srgbClr val="FFE58F"/>
-                </a:highlight>
-                <a:latin typeface="Google Sans Flex SemiBold"/>
-              </a:rPr>
-              <a:t>[TBD: video URL]</a:t>
-            </a:r>
-          </a:p>
-        </p:txBody>
-      </p:sp>
-      <p:sp>
-        <p:nvSpPr>
-          <p:cNvPr id="171" name="link note"/>
-          <p:cNvSpPr txBox="1"/>
-          <p:nvPr/>
-        </p:nvSpPr>
-        <p:spPr>
-          <a:xfrm>
-            <a:off x="1225296" y="3054096"/>
-            <a:ext cx="6172200" cy="219456"/>
-          </a:xfrm>
-          <a:prstGeom prst="rect">
-            <a:avLst/>
-          </a:prstGeom>
-          <a:noFill/>
-        </p:spPr>
-        <p:txBody>
-          <a:bodyPr wrap="square" lIns="0" tIns="0" rIns="0" bIns="0" anchor="t">
-            <a:noAutofit/>
-          </a:bodyPr>
-          <a:lstStyle/>
-          <a:p>
-            <a:pPr algn="l" marL="0" indent="0">
-              <a:lnSpc>
-                <a:spcPct val="100000"/>
-              </a:lnSpc>
-              <a:buNone/>
-            </a:pPr>
-            <a:r>
-              <a:rPr sz="950" b="0" lang="en-GB">
-                <a:solidFill>
-                  <a:srgbClr val="5F6368"/>
-                </a:solidFill>
-                <a:latin typeface="Google Sans Flex"/>
-              </a:rPr>
-              <a:t>(runs 2:45)</a:t>
-            </a:r>
-          </a:p>
-        </p:txBody>
-      </p:sp>
-      <p:sp>
-        <p:nvSpPr>
-          <p:cNvPr id="172" name="QR placeholder"/>
-          <p:cNvSpPr/>
-          <p:nvPr/>
-        </p:nvSpPr>
-        <p:spPr>
-          <a:xfrm>
-            <a:off x="7781544" y="2450592"/>
-            <a:ext cx="822960" cy="822960"/>
-          </a:xfrm>
-          <a:prstGeom prst="roundRect">
-            <a:avLst>
-              <a:gd name="adj" fmla="val 6666"/>
-            </a:avLst>
-          </a:prstGeom>
-          <a:solidFill>
-            <a:srgbClr val="FFFFFF"/>
-          </a:solidFill>
-          <a:ln w="12700">
-            <a:solidFill>
-              <a:srgbClr val="C2410C"/>
-            </a:solidFill>
-            <a:prstDash val="dash"/>
-          </a:ln>
-        </p:spPr>
-        <p:txBody>
-          <a:bodyPr rtlCol="0" anchor="ctr" lIns="54864" rIns="54864" tIns="36576" bIns="36576" wrap="square">
-            <a:noAutofit/>
-          </a:bodyPr>
-          <a:lstStyle/>
-          <a:p>
-            <a:pPr algn="ctr" marL="0" indent="0">
-              <a:lnSpc>
-                <a:spcPct val="100000"/>
-              </a:lnSpc>
-              <a:buNone/>
-            </a:pPr>
-            <a:r>
-              <a:rPr sz="650" b="0" lang="en-GB">
-                <a:solidFill>
-                  <a:srgbClr val="9A3412"/>
-                </a:solidFill>
-                <a:latin typeface="Google Sans Flex"/>
-              </a:rPr>
-              <a:t>QR appears</a:t>
-            </a:r>
-          </a:p>
-          <a:p>
-            <a:pPr algn="ctr" marL="0" indent="0">
-              <a:lnSpc>
-                <a:spcPct val="100000"/>
-              </a:lnSpc>
-              <a:buNone/>
-            </a:pPr>
-            <a:r>
-              <a:rPr sz="650" b="0" lang="en-GB">
-                <a:solidFill>
-                  <a:srgbClr val="9A3412"/>
-                </a:solidFill>
-                <a:latin typeface="Google Sans Flex"/>
-              </a:rPr>
-              <a:t>when the</a:t>
-            </a:r>
-          </a:p>
-          <a:p>
-            <a:pPr algn="ctr" marL="0" indent="0">
-              <a:lnSpc>
-                <a:spcPct val="100000"/>
-              </a:lnSpc>
-              <a:buNone/>
-            </a:pPr>
-            <a:r>
-              <a:rPr sz="650" b="0" lang="en-GB">
-                <a:solidFill>
-                  <a:srgbClr val="9A3412"/>
-                </a:solidFill>
-                <a:latin typeface="Google Sans Flex"/>
-              </a:rPr>
-              <a:t>URL is filled</a:t>
-            </a:r>
-          </a:p>
-        </p:txBody>
-      </p:sp>
-      <p:sp>
-        <p:nvSpPr>
-          <p:cNvPr id="173" name="link row"/>
-          <p:cNvSpPr/>
-          <p:nvPr/>
-        </p:nvSpPr>
-        <p:spPr>
-          <a:xfrm>
-            <a:off x="356616" y="3511296"/>
-            <a:ext cx="8430768" cy="1078992"/>
-          </a:xfrm>
-          <a:prstGeom prst="roundRect">
-            <a:avLst>
-              <a:gd name="adj" fmla="val 6779"/>
-            </a:avLst>
-          </a:prstGeom>
-          <a:solidFill>
-            <a:srgbClr val="F8F9FA"/>
-          </a:solidFill>
-          <a:ln w="9525">
-            <a:solidFill>
-              <a:srgbClr val="E8EAED"/>
-            </a:solidFill>
-          </a:ln>
-        </p:spPr>
-        <p:txBody>
-          <a:bodyPr rtlCol="0" anchor="ctr" lIns="0" rIns="0" tIns="0" bIns="0"/>
-          <a:lstStyle/>
-          <a:p>
-            <a:pPr algn="ctr"/>
-          </a:p>
-        </p:txBody>
-      </p:sp>
-      <p:sp>
-        <p:nvSpPr>
           <p:cNvPr id="174" name="badge globe"/>
           <p:cNvSpPr/>
           <p:nvPr/>
@@ -12954,7 +12898,7 @@
           <p:nvPr/>
         </p:nvPicPr>
         <p:blipFill>
-          <a:blip r:embed="rId7"/>
+          <a:blip r:embed="rId9"/>
           <a:stretch>
             <a:fillRect/>
           </a:stretch>
@@ -13043,7 +12987,7 @@
                   <a:srgbClr val="202124"/>
                 </a:solidFill>
                 <a:latin typeface="Roboto Mono"/>
-                <a:hlinkClick r:id="rId8">
+                <a:hlinkClick r:id="rId10">
                   <a:extLst>
                     <a:ext uri="{A12FA001-AC4F-418D-AE19-62706E023703}">
                       <ahyp:hlinkClr val="tx"/>
@@ -13105,7 +13049,7 @@
           <p:nvPr/>
         </p:nvPicPr>
         <p:blipFill>
-          <a:blip r:embed="rId9"/>
+          <a:blip r:embed="rId11"/>
           <a:stretch>
             <a:fillRect/>
           </a:stretch>
@@ -13310,41 +13254,9 @@
           </a:p>
         </p:txBody>
       </p:sp>
-      <p:sp>
-        <p:nvSpPr>
-          <p:cNvPr id="169" name="photo placeholder"/>
-          <p:cNvSpPr/>
-          <p:nvPr/>
-        </p:nvSpPr>
-        <p:spPr>
-          <a:xfrm>
-            <a:off x="585216" y="1408176"/>
-            <a:ext cx="1371600" cy="1371600"/>
-          </a:xfrm>
-          <a:prstGeom prst="ellipse">
-            <a:avLst/>
-          </a:prstGeom>
-          <a:solidFill>
-            <a:srgbClr val="FFF4EC"/>
-          </a:solidFill>
-          <a:ln w="12700">
-            <a:solidFill>
-              <a:srgbClr val="C2410C"/>
-            </a:solidFill>
-            <a:prstDash val="dash"/>
-          </a:ln>
-        </p:spPr>
-        <p:txBody>
-          <a:bodyPr rtlCol="0" anchor="ctr" lIns="0" rIns="0" tIns="0" bIns="0"/>
-          <a:lstStyle/>
-          <a:p>
-            <a:pPr algn="ctr"/>
-          </a:p>
-        </p:txBody>
-      </p:sp>
       <p:pic>
         <p:nvPicPr>
-          <p:cNvPr id="170" name="icon user" descr=""/>
+          <p:cNvPr id="169" name="photo Mehul Arora" descr="mehul.jpg"/>
           <p:cNvPicPr>
             <a:picLocks noChangeAspect="1"/>
           </p:cNvPicPr>
@@ -13352,63 +13264,24 @@
         </p:nvPicPr>
         <p:blipFill>
           <a:blip r:embed="rId5"/>
+          <a:srcRect/>
           <a:stretch>
             <a:fillRect/>
           </a:stretch>
         </p:blipFill>
         <p:spPr>
           <a:xfrm>
-            <a:off x="1042416" y="1664208"/>
-            <a:ext cx="457200" cy="457200"/>
-          </a:xfrm>
-          <a:prstGeom prst="rect">
+            <a:off x="585216" y="1408176"/>
+            <a:ext cx="1371600" cy="1371600"/>
+          </a:xfrm>
+          <a:prstGeom prst="ellipse">
             <a:avLst/>
           </a:prstGeom>
         </p:spPr>
       </p:pic>
       <p:sp>
         <p:nvSpPr>
-          <p:cNvPr id="171" name="photo label"/>
-          <p:cNvSpPr txBox="1"/>
-          <p:nvPr/>
-        </p:nvSpPr>
-        <p:spPr>
-          <a:xfrm>
-            <a:off x="722376" y="2194560"/>
-            <a:ext cx="1097280" cy="365760"/>
-          </a:xfrm>
-          <a:prstGeom prst="rect">
-            <a:avLst/>
-          </a:prstGeom>
-          <a:noFill/>
-        </p:spPr>
-        <p:txBody>
-          <a:bodyPr wrap="square" lIns="0" tIns="0" rIns="0" bIns="0" anchor="t">
-            <a:noAutofit/>
-          </a:bodyPr>
-          <a:lstStyle/>
-          <a:p>
-            <a:pPr algn="ctr" marL="0" indent="0">
-              <a:lnSpc>
-                <a:spcPct val="100000"/>
-              </a:lnSpc>
-              <a:buNone/>
-            </a:pPr>
-            <a:r>
-              <a:rPr sz="650" b="0" lang="en-GB">
-                <a:solidFill>
-                  <a:srgbClr val="9A3412"/>
-                </a:solidFill>
-                <a:latin typeface="Roboto Mono"/>
-              </a:rPr>
-              <a:t>PHOTO · photos.mehul</a:t>
-            </a:r>
-          </a:p>
-        </p:txBody>
-      </p:sp>
-      <p:sp>
-        <p:nvSpPr>
-          <p:cNvPr id="172" name="person name"/>
+          <p:cNvPr id="170" name="person name"/>
           <p:cNvSpPr txBox="1"/>
           <p:nvPr/>
         </p:nvSpPr>
@@ -13448,7 +13321,7 @@
       </p:sp>
       <p:sp>
         <p:nvSpPr>
-          <p:cNvPr id="173" name="person role"/>
+          <p:cNvPr id="171" name="person role"/>
           <p:cNvSpPr txBox="1"/>
           <p:nvPr/>
         </p:nvSpPr>
@@ -13500,7 +13373,7 @@
       </p:sp>
       <p:sp>
         <p:nvSpPr>
-          <p:cNvPr id="174" name="person card"/>
+          <p:cNvPr id="172" name="person card"/>
           <p:cNvSpPr/>
           <p:nvPr/>
         </p:nvSpPr>
@@ -13531,105 +13404,34 @@
           </a:p>
         </p:txBody>
       </p:sp>
-      <p:sp>
-        <p:nvSpPr>
-          <p:cNvPr id="175" name="photo placeholder"/>
-          <p:cNvSpPr/>
-          <p:nvPr/>
-        </p:nvSpPr>
-        <p:spPr>
-          <a:xfrm>
-            <a:off x="4937760" y="1408176"/>
-            <a:ext cx="1371600" cy="1371600"/>
-          </a:xfrm>
-          <a:prstGeom prst="ellipse">
-            <a:avLst/>
-          </a:prstGeom>
-          <a:solidFill>
-            <a:srgbClr val="FFF4EC"/>
-          </a:solidFill>
-          <a:ln w="12700">
-            <a:solidFill>
-              <a:srgbClr val="C2410C"/>
-            </a:solidFill>
-            <a:prstDash val="dash"/>
-          </a:ln>
-        </p:spPr>
-        <p:txBody>
-          <a:bodyPr rtlCol="0" anchor="ctr" lIns="0" rIns="0" tIns="0" bIns="0"/>
-          <a:lstStyle/>
-          <a:p>
-            <a:pPr algn="ctr"/>
-          </a:p>
-        </p:txBody>
-      </p:sp>
       <p:pic>
         <p:nvPicPr>
-          <p:cNvPr id="176" name="icon user" descr=""/>
+          <p:cNvPr id="173" name="photo Jayadratha" descr="jayadratha.jpg"/>
           <p:cNvPicPr>
             <a:picLocks noChangeAspect="1"/>
           </p:cNvPicPr>
           <p:nvPr/>
         </p:nvPicPr>
         <p:blipFill>
-          <a:blip r:embed="rId5"/>
+          <a:blip r:embed="rId6"/>
+          <a:srcRect/>
           <a:stretch>
             <a:fillRect/>
           </a:stretch>
         </p:blipFill>
         <p:spPr>
           <a:xfrm>
-            <a:off x="5394960" y="1664208"/>
-            <a:ext cx="457200" cy="457200"/>
-          </a:xfrm>
-          <a:prstGeom prst="rect">
+            <a:off x="4937760" y="1408176"/>
+            <a:ext cx="1371600" cy="1371600"/>
+          </a:xfrm>
+          <a:prstGeom prst="ellipse">
             <a:avLst/>
           </a:prstGeom>
         </p:spPr>
       </p:pic>
       <p:sp>
         <p:nvSpPr>
-          <p:cNvPr id="177" name="photo label"/>
-          <p:cNvSpPr txBox="1"/>
-          <p:nvPr/>
-        </p:nvSpPr>
-        <p:spPr>
-          <a:xfrm>
-            <a:off x="5074920" y="2194560"/>
-            <a:ext cx="1097280" cy="365760"/>
-          </a:xfrm>
-          <a:prstGeom prst="rect">
-            <a:avLst/>
-          </a:prstGeom>
-          <a:noFill/>
-        </p:spPr>
-        <p:txBody>
-          <a:bodyPr wrap="square" lIns="0" tIns="0" rIns="0" bIns="0" anchor="t">
-            <a:noAutofit/>
-          </a:bodyPr>
-          <a:lstStyle/>
-          <a:p>
-            <a:pPr algn="ctr" marL="0" indent="0">
-              <a:lnSpc>
-                <a:spcPct val="100000"/>
-              </a:lnSpc>
-              <a:buNone/>
-            </a:pPr>
-            <a:r>
-              <a:rPr sz="650" b="0" lang="en-GB">
-                <a:solidFill>
-                  <a:srgbClr val="9A3412"/>
-                </a:solidFill>
-                <a:latin typeface="Roboto Mono"/>
-              </a:rPr>
-              <a:t>PHOTO · photos.jayadratha</a:t>
-            </a:r>
-          </a:p>
-        </p:txBody>
-      </p:sp>
-      <p:sp>
-        <p:nvSpPr>
-          <p:cNvPr id="178" name="person name"/>
+          <p:cNvPr id="174" name="person name"/>
           <p:cNvSpPr txBox="1"/>
           <p:nvPr/>
         </p:nvSpPr>
@@ -13669,7 +13471,7 @@
       </p:sp>
       <p:sp>
         <p:nvSpPr>
-          <p:cNvPr id="179" name="person role"/>
+          <p:cNvPr id="175" name="person role"/>
           <p:cNvSpPr txBox="1"/>
           <p:nvPr/>
         </p:nvSpPr>
@@ -13712,7 +13514,7 @@
       </p:sp>
       <p:sp>
         <p:nvSpPr>
-          <p:cNvPr id="180" name="closing"/>
+          <p:cNvPr id="176" name="closing"/>
           <p:cNvSpPr txBox="1"/>
           <p:nvPr/>
         </p:nvSpPr>
@@ -13752,7 +13554,7 @@
       </p:sp>
       <p:sp>
         <p:nvSpPr>
-          <p:cNvPr id="181" name="theme strip"/>
+          <p:cNvPr id="177" name="theme strip"/>
           <p:cNvSpPr/>
           <p:nvPr/>
         </p:nvSpPr>
@@ -13785,7 +13587,7 @@
       </p:sp>
       <p:sp>
         <p:nvSpPr>
-          <p:cNvPr id="182" name="theme label"/>
+          <p:cNvPr id="178" name="theme label"/>
           <p:cNvSpPr txBox="1"/>
           <p:nvPr/>
         </p:nvSpPr>
@@ -13825,7 +13627,7 @@
       </p:sp>
       <p:sp>
         <p:nvSpPr>
-          <p:cNvPr id="183" name="theme value"/>
+          <p:cNvPr id="179" name="theme value"/>
           <p:cNvSpPr txBox="1"/>
           <p:nvPr/>
         </p:nvSpPr>

</xml_diff>

<commit_message>
docs(submission): team roles and bios on slide 15 (no titles)
Co-Authored-By: Claude Opus 5.5 (1M context) <noreply@anthropic.com>
</commit_message>
<xml_diff>
--- a/docs/submission/deck/Kirchhoff-AI-Builder-Cup.pptx
+++ b/docs/submission/deck/Kirchhoff-AI-Builder-Cup.pptx
@@ -1435,7 +1435,7 @@
           <a:lstStyle/>
           <a:p>
             <a:r>
-              <a:t>[TBD: two sentences per person on what each of us built and the background that makes us credible here.] We built Kirchhoff from scratch during the hackathon window, on Google Cloud end to end.</a:t>
+              <a:t>Mehul Arora built Kirchhoff's agent layer, its deterministic engine and the web app. He builds production multi-agent LLM systems on Gemini, Google ADK and Cloud Run, and earlier did graph neural network research for his MS by Research at IIIT Hyderabad and data science on US power-market datasets. Jayadratha Gayen built the bids inbox, the asset agent and the end-to-end test suite, and ran Kirchhoff's cloud deployments and golden capture. He is a graph neural networks researcher and previously worked at Vikram Solar, bringing solar and energy-sector experience. We built Kirchhoff from scratch during the hackathon window, on Google Cloud end to end.</a:t>
             </a:r>
           </a:p>
         </p:txBody>
@@ -13348,7 +13348,7 @@
               <a:buNone/>
             </a:pPr>
             <a:r>
-              <a:rPr sz="1100" b="0" lang="en-GB">
+              <a:rPr sz="950" b="0" lang="en-GB">
                 <a:solidFill>
                   <a:srgbClr val="3C4043"/>
                 </a:solidFill>
@@ -13357,16 +13357,13 @@
               <a:t>Team lead. </a:t>
             </a:r>
             <a:r>
-              <a:rPr sz="1100" b="0" lang="en-GB">
-                <a:solidFill>
-                  <a:srgbClr val="5C3D00"/>
-                </a:solidFill>
-                <a:highlight>
-                  <a:srgbClr val="FFE58F"/>
-                </a:highlight>
-                <a:latin typeface="Google Sans Flex SemiBold"/>
-              </a:rPr>
-              <a:t>[TBD: role and one-line background]</a:t>
+              <a:rPr sz="950" b="0" lang="en-GB">
+                <a:solidFill>
+                  <a:srgbClr val="3C4043"/>
+                </a:solidFill>
+                <a:latin typeface="Google Sans Flex"/>
+              </a:rPr>
+              <a:t>AI engineer · built Kirchhoff's agents, engine and app; builds production multi-agent systems on Gemini and Google ADK; MS by Research in ML, IIIT Hyderabad</a:t>
             </a:r>
           </a:p>
         </p:txBody>
@@ -13500,14 +13497,11 @@
             <a:r>
               <a:rPr sz="1100" b="0" lang="en-GB">
                 <a:solidFill>
-                  <a:srgbClr val="5C3D00"/>
-                </a:solidFill>
-                <a:highlight>
-                  <a:srgbClr val="FFE58F"/>
-                </a:highlight>
-                <a:latin typeface="Google Sans Flex SemiBold"/>
-              </a:rPr>
-              <a:t>[TBD: role and one-line background]</a:t>
+                  <a:srgbClr val="3C4043"/>
+                </a:solidFill>
+                <a:latin typeface="Google Sans Flex"/>
+              </a:rPr>
+              <a:t>Graph ML researcher · built the bids inbox, asset agent and test suite, ran cloud and the golden capture; previously at Vikram Solar</a:t>
             </a:r>
           </a:p>
         </p:txBody>

</xml_diff>

<commit_message>
docs(submission): Jayadratha's role and bio from his profile (EE, Vikram Solar, grid ops, graph ML)
Co-Authored-By: Claude Opus 5.5 (1M context) <noreply@anthropic.com>
</commit_message>
<xml_diff>
--- a/docs/submission/deck/Kirchhoff-AI-Builder-Cup.pptx
+++ b/docs/submission/deck/Kirchhoff-AI-Builder-Cup.pptx
@@ -1435,7 +1435,7 @@
           <a:lstStyle/>
           <a:p>
             <a:r>
-              <a:t>Mehul Arora built Kirchhoff's agent layer, its deterministic engine and the web app. He builds production multi-agent LLM systems on Gemini, Google ADK and Cloud Run, and earlier did graph neural network research for his MS by Research at IIIT Hyderabad and data science on US power-market datasets. Jayadratha Gayen built the bids inbox, the asset agent and the end-to-end test suite, and ran Kirchhoff's cloud deployments and golden capture. He is a graph neural networks researcher and previously worked at Vikram Solar, bringing solar and energy-sector experience. We built Kirchhoff from scratch during the hackathon window, on Google Cloud end to end.</a:t>
+              <a:t>Mehul Arora built Kirchhoff's agent layer, its deterministic engine and the web app. He builds production multi-agent LLM systems on Gemini, Google ADK and Cloud Run, and earlier did graph neural network research for his MS by Research at IIIT Hyderabad and data science on US power-market datasets. Jayadratha Gayen built the bids inbox, the asset agent and the end-to-end test suite, and ran Kirchhoff's cloud deployments and golden capture. He is an electrical engineer (B.Tech, IIEST Shibpur) who worked at Vikram Solar and trained in grid operations at the Eastern Regional Load Despatch Centre, and an AI research engineer with an MS by Research in graph machine learning from IIIT Hyderabad, published at TMLR and ASONAM 2025. We built Kirchhoff from scratch during the hackathon window, on Google Cloud end to end.</a:t>
             </a:r>
           </a:p>
         </p:txBody>
@@ -13495,13 +13495,13 @@
               <a:buNone/>
             </a:pPr>
             <a:r>
-              <a:rPr sz="1100" b="0" lang="en-GB">
+              <a:rPr sz="950" b="0" lang="en-GB">
                 <a:solidFill>
                   <a:srgbClr val="3C4043"/>
                 </a:solidFill>
                 <a:latin typeface="Google Sans Flex"/>
               </a:rPr>
-              <a:t>Graph ML researcher · built the bids inbox, asset agent and test suite, ran cloud and the golden capture; previously at Vikram Solar</a:t>
+              <a:t>AI research engineer · electrical engineer (IIEST Shibpur, Vikram Solar) with an MS by Research in graph ML, IIIT Hyderabad; built the bids inbox, asset agent and test suite, ran cloud</a:t>
             </a:r>
           </a:p>
         </p:txBody>

</xml_diff>

<commit_message>
docs(submission): deck numbers from the golden capture and live runs (cost, time to clean, intake recall range); spec markers verified; UTF-8 fill read
Co-Authored-By: Claude Opus 5.5 (1M context) <noreply@anthropic.com>
</commit_message>
<xml_diff>
--- a/docs/submission/deck/Kirchhoff-AI-Builder-Cup.pptx
+++ b/docs/submission/deck/Kirchhoff-AI-Builder-Cup.pptx
@@ -894,7 +894,7 @@
           <a:lstStyle/>
           <a:p>
             <a:r>
-              <a:t>Cost. The prototype runs on one warm API instance with no CPU throttling, scaling to a maximum of 3 (spec). The enterprise sandbox is a second small service. Gemini 3.8 Flash costs $0.75 per million input tokens and $3.75 per million output tokens through 31 December 2026, and the price doubles from 1 January 2027.¹² The engine does the heavy work without tokens. A what-if runs in about 8 ms and makes no LLM call. Budget alerts fire at 50% and 90% (spec). Measured on a live run, 15 Oct 2026: a full P1→P4 run on Vertex AI took 176.5 s and used 10,432 input tokens and 12,991 output tokens, about $0.057 per design at $0.75 per million input and $3.75 per million output tokens. The golden capture may replace this figure.</a:t>
+              <a:t>Cost. The prototype runs on one warm API instance with no CPU throttling, scaling to a maximum of 3 (spec). The enterprise sandbox is a second small service. Gemini 3.8 Flash costs $0.75 per million input tokens and $3.75 per million output tokens through 31 December 2026, and the price doubles from 1 January 2027.¹² The engine does the heavy work without tokens. A what-if runs in about 8 ms and makes no LLM call. Budget alerts fire at 50% and 90% (spec). Measured on the golden-capture run on Vertex AI, 16 Oct 2026: a full P1→P4 run took 177.5 s and used 10,628 input and 15,566 output tokens, about $0.066 per design at $0.75 per million input and $3.75 per million output tokens; two other live runs cost $0.068 and $0.101.</a:t>
             </a:r>
           </a:p>
           <a:p/>
@@ -1146,7 +1146,7 @@
           <a:p/>
           <a:p>
             <a:r>
-              <a:t>Impact estimate, labelled as an estimate. We estimate about 10 engineer-hours saved per design-change iteration. The basis is the industry's own figure for reworking a design change by hand: "10+ hours", from Endra's September 2026 launch demo.¹³ That figure is unaudited and comes from commercial buildings.¹⁴ Kirchhoff re-checks every rule in milliseconds, and the engineer's time goes to review rather than recalculation. The spec's first-design baseline is 4–8 weeks for a first coordinated electrical package (spec; [TBD: source citation]). Kirchhoff produces a checked concept design, not construction drawings, so the honest comparison is first checked concept against first concept. [TBD: measured time from upload to a checker-clean revision, median of 5 live runs, excluding time at human gates (spec §4, metric 1).] Measured on a live intake run on Vertex AI, 15 Oct 2026: requirement recall 0.84 against our hand-labelled ground truth for the Hall A tender, with 27 of 28 extracted quotes verified word for word against the tender PDF; the one unverified quote was shown as unverified, never as fact.</a:t>
+              <a:t>Impact estimate, labelled as an estimate. We estimate about 10 engineer-hours saved per design-change iteration. The basis is the industry's own figure for reworking a design change by hand: "10+ hours", from Endra's September 2026 launch demo.¹³ That figure is unaudited and comes from commercial buildings.¹⁴ Kirchhoff re-checks every rule in milliseconds, and the engineer's time goes to review rather than recalculation. The spec's first-design baseline is 4–8 weeks for a first coordinated electrical package (spec; [TBD: source citation]). Kirchhoff produces a checked concept design, not construction drawings, so the honest comparison is first checked concept against first concept. Median 149 s from the start of a run to a checker-clean revision over 3 live runs on the deployed site (143.8 s, 149.2 s and 211.4 s), excluding the time spent waiting at gates. Requirement recall of 0.78 to 0.84 against our hand-labelled ground truth over four live runs (0.78 on the golden-capture run the site shows), with 25 of 26 extracted quotes verified word for word against the tender PDF on that run; unverified quotes are shown as unverified, never as fact.</a:t>
             </a:r>
           </a:p>
         </p:txBody>
@@ -1435,7 +1435,7 @@
           <a:lstStyle/>
           <a:p>
             <a:r>
-              <a:t>Mehul Arora built Kirchhoff's agent layer, its deterministic engine and the web app. He builds production multi-agent LLM systems on Gemini, Google ADK and Cloud Run, and earlier did graph neural network research for his MS by Research at IIIT Hyderabad and data science on US power-market datasets. Jayadratha Gayen built the bids inbox, the asset agent and the end-to-end test suite, and ran Kirchhoff's cloud deployments and golden capture. He is an electrical engineer (B.Tech, IIEST Shibpur) who worked at Vikram Solar and trained in grid operations at the Eastern Regional Load Despatch Centre, and an AI research engineer with an MS by Research in graph machine learning from IIIT Hyderabad, published at TMLR and ASONAM 2025. We built Kirchhoff from scratch during the hackathon window, on Google Cloud end to end.</a:t>
+              <a:t>Mehul Arora built Kirchhoff's agent layer, its deterministic engine and the web app. He builds production multi-agent LLM systems on Gemini, Google ADK and Cloud Run, and earlier did graph neural network research for his MS by Research at IIIT Hyderabad and data science on US power-market datasets. Jayadratha Gayen built the bids inbox, the asset agent and the end-to-end test suite, and ran Kirchhoff's cloud deployments and golden capture. He is an electrical engineer (B.Tech, IIEST Shibpur) who worked at Vikram Solar and trained in grid operations at the Eastern Regional Load Despatch Centre, and an AI research engineer with an MS by Research in graph machine learning from IIIT Hyderabad, published at TMLR and ASONAM 2025, and a GSoC 2025 contributor (INCF); he also trained on low- and high-tension systems at CESC. We built Kirchhoff from scratch during the hackathon window, on Google Cloud end to end.</a:t>
             </a:r>
           </a:p>
         </p:txBody>
@@ -7921,7 +7921,7 @@
                 <a:spcPct val="100000"/>
               </a:lnSpc>
               <a:spcAft>
-                <a:spcPts val="380"/>
+                <a:spcPts val="370"/>
               </a:spcAft>
               <a:buClr>
                 <a:srgbClr val="80868B"/>
@@ -7930,7 +7930,7 @@
               <a:buChar char="•"/>
             </a:pPr>
             <a:r>
-              <a:rPr sz="1150" b="0" lang="en-GB">
+              <a:rPr sz="1100" b="0" lang="en-GB">
                 <a:solidFill>
                   <a:srgbClr val="3C4043"/>
                 </a:solidFill>
@@ -7938,18 +7938,6 @@
               </a:rPr>
               <a:t>1 warm Cloud Run instance</a:t>
             </a:r>
-            <a:r>
-              <a:rPr sz="900" b="0" lang="en-GB">
-                <a:solidFill>
-                  <a:srgbClr val="8A4B00"/>
-                </a:solidFill>
-                <a:highlight>
-                  <a:srgbClr val="FDEBD0"/>
-                </a:highlight>
-                <a:latin typeface="Google Sans Flex"/>
-              </a:rPr>
-              <a:t> (spec)</a:t>
-            </a:r>
           </a:p>
           <a:p>
             <a:pPr algn="l" marL="146304" indent="-146304">
@@ -7957,7 +7945,7 @@
                 <a:spcPct val="100000"/>
               </a:lnSpc>
               <a:spcAft>
-                <a:spcPts val="380"/>
+                <a:spcPts val="370"/>
               </a:spcAft>
               <a:buClr>
                 <a:srgbClr val="80868B"/>
@@ -7966,7 +7954,7 @@
               <a:buChar char="•"/>
             </a:pPr>
             <a:r>
-              <a:rPr sz="1150" b="0" lang="en-GB">
+              <a:rPr sz="1100" b="0" lang="en-GB">
                 <a:solidFill>
                   <a:srgbClr val="3C4043"/>
                 </a:solidFill>
@@ -7974,18 +7962,6 @@
               </a:rPr>
               <a:t>USD 200 budget with alerts</a:t>
             </a:r>
-            <a:r>
-              <a:rPr sz="900" b="0" lang="en-GB">
-                <a:solidFill>
-                  <a:srgbClr val="8A4B00"/>
-                </a:solidFill>
-                <a:highlight>
-                  <a:srgbClr val="FDEBD0"/>
-                </a:highlight>
-                <a:latin typeface="Google Sans Flex"/>
-              </a:rPr>
-              <a:t> (spec)</a:t>
-            </a:r>
           </a:p>
           <a:p>
             <a:pPr algn="l" marL="146304" indent="-146304">
@@ -7993,7 +7969,7 @@
                 <a:spcPct val="100000"/>
               </a:lnSpc>
               <a:spcAft>
-                <a:spcPts val="380"/>
+                <a:spcPts val="370"/>
               </a:spcAft>
               <a:buClr>
                 <a:srgbClr val="80868B"/>
@@ -8002,7 +7978,7 @@
               <a:buChar char="•"/>
             </a:pPr>
             <a:r>
-              <a:rPr sz="1150" b="0" lang="en-GB">
+              <a:rPr sz="1100" b="0" lang="en-GB">
                 <a:solidFill>
                   <a:srgbClr val="3C4043"/>
                 </a:solidFill>
@@ -8017,7 +7993,7 @@
                 <a:spcPct val="100000"/>
               </a:lnSpc>
               <a:spcAft>
-                <a:spcPts val="380"/>
+                <a:spcPts val="370"/>
               </a:spcAft>
               <a:buClr>
                 <a:srgbClr val="80868B"/>
@@ -8026,7 +8002,7 @@
               <a:buChar char="•"/>
             </a:pPr>
             <a:r>
-              <a:rPr sz="1150" b="0" lang="en-GB">
+              <a:rPr sz="1100" b="0" lang="en-GB">
                 <a:solidFill>
                   <a:srgbClr val="3C4043"/>
                 </a:solidFill>
@@ -8035,13 +8011,13 @@
               <a:t>Per design: </a:t>
             </a:r>
             <a:r>
-              <a:rPr sz="1150" b="0" lang="en-GB">
+              <a:rPr sz="1100" b="0" lang="en-GB">
                 <a:solidFill>
                   <a:srgbClr val="3C4043"/>
                 </a:solidFill>
                 <a:latin typeface="Google Sans Flex"/>
               </a:rPr>
-              <a:t>~$0.057 (measured on a live run, 15 Oct 2026)</a:t>
+              <a:t>~$0.066 (measured on the golden-capture run, 16 Oct 2026)</a:t>
             </a:r>
           </a:p>
         </p:txBody>
@@ -16381,18 +16357,6 @@
               </a:rPr>
               <a:t>2N, DR, block</a:t>
             </a:r>
-            <a:r>
-              <a:rPr sz="650" b="0" lang="en-GB">
-                <a:solidFill>
-                  <a:srgbClr val="8A4B00"/>
-                </a:solidFill>
-                <a:highlight>
-                  <a:srgbClr val="FDEBD0"/>
-                </a:highlight>
-                <a:latin typeface="Google Sans Flex Medium"/>
-              </a:rPr>
-              <a:t> (spec)</a:t>
-            </a:r>
           </a:p>
         </p:txBody>
       </p:sp>
@@ -19696,18 +19660,6 @@
                 <a:latin typeface="Google Sans Flex Medium"/>
               </a:rPr>
               <a:t>Four phases. Three gates. One signed revision.</a:t>
-            </a:r>
-            <a:r>
-              <a:rPr sz="1150" b="0" lang="en-GB">
-                <a:solidFill>
-                  <a:srgbClr val="8A4B00"/>
-                </a:solidFill>
-                <a:highlight>
-                  <a:srgbClr val="FDEBD0"/>
-                </a:highlight>
-                <a:latin typeface="Google Sans Flex Medium"/>
-              </a:rPr>
-              <a:t> (spec)</a:t>
             </a:r>
           </a:p>
         </p:txBody>

</xml_diff>